<commit_message>
NO APM ROLE SPECIFIC
</commit_message>
<xml_diff>
--- a/public/downloads/Ownly_Pitch_Deck.pptx
+++ b/public/downloads/Ownly_Pitch_Deck.pptx
@@ -1993,6 +1993,10 @@
             <a:prstDash val="solid"/>
           </a:ln>
         </p:spPr>
+        <p:txBody>
+          <a:bodyPr/>
+          <a:p/>
+        </p:txBody>
       </p:sp>
       <p:sp>
         <p:nvSpPr>
@@ -2337,6 +2341,10 @@
             <a:prstDash val="solid"/>
           </a:ln>
         </p:spPr>
+        <p:txBody>
+          <a:bodyPr/>
+          <a:p/>
+        </p:txBody>
       </p:sp>
       <p:sp>
         <p:nvSpPr>
@@ -2446,6 +2454,10 @@
             <a:prstDash val="solid"/>
           </a:ln>
         </p:spPr>
+        <p:txBody>
+          <a:bodyPr/>
+          <a:p/>
+        </p:txBody>
       </p:sp>
       <p:sp>
         <p:nvSpPr>
@@ -2555,6 +2567,10 @@
             <a:prstDash val="solid"/>
           </a:ln>
         </p:spPr>
+        <p:txBody>
+          <a:bodyPr/>
+          <a:p/>
+        </p:txBody>
       </p:sp>
       <p:sp>
         <p:nvSpPr>
@@ -2811,6 +2827,10 @@
             <a:prstDash val="solid"/>
           </a:ln>
         </p:spPr>
+        <p:txBody>
+          <a:bodyPr/>
+          <a:p/>
+        </p:txBody>
       </p:sp>
       <p:sp>
         <p:nvSpPr>
@@ -2994,6 +3014,10 @@
             <a:prstDash val="solid"/>
           </a:ln>
         </p:spPr>
+        <p:txBody>
+          <a:bodyPr/>
+          <a:p/>
+        </p:txBody>
       </p:sp>
       <p:sp>
         <p:nvSpPr>
@@ -3375,6 +3399,10 @@
             <a:prstDash val="solid"/>
           </a:ln>
         </p:spPr>
+        <p:txBody>
+          <a:bodyPr/>
+          <a:p/>
+        </p:txBody>
       </p:sp>
       <p:sp>
         <p:nvSpPr>
@@ -3519,6 +3547,10 @@
             <a:prstDash val="solid"/>
           </a:ln>
         </p:spPr>
+        <p:txBody>
+          <a:bodyPr/>
+          <a:p/>
+        </p:txBody>
       </p:sp>
       <p:sp>
         <p:nvSpPr>
@@ -3663,6 +3695,10 @@
             <a:prstDash val="solid"/>
           </a:ln>
         </p:spPr>
+        <p:txBody>
+          <a:bodyPr/>
+          <a:p/>
+        </p:txBody>
       </p:sp>
       <p:sp>
         <p:nvSpPr>
@@ -3807,6 +3843,10 @@
             <a:prstDash val="solid"/>
           </a:ln>
         </p:spPr>
+        <p:txBody>
+          <a:bodyPr/>
+          <a:p/>
+        </p:txBody>
       </p:sp>
       <p:sp>
         <p:nvSpPr>
@@ -3998,6 +4038,10 @@
             <a:prstDash val="solid"/>
           </a:ln>
         </p:spPr>
+        <p:txBody>
+          <a:bodyPr/>
+          <a:p/>
+        </p:txBody>
       </p:sp>
       <p:sp>
         <p:nvSpPr>
@@ -4023,6 +4067,10 @@
             <a:prstDash val="solid"/>
           </a:ln>
         </p:spPr>
+        <p:txBody>
+          <a:bodyPr/>
+          <a:p/>
+        </p:txBody>
       </p:sp>
       <p:sp>
         <p:nvSpPr>
@@ -4204,6 +4252,10 @@
             <a:prstDash val="solid"/>
           </a:ln>
         </p:spPr>
+        <p:txBody>
+          <a:bodyPr/>
+          <a:p/>
+        </p:txBody>
       </p:sp>
       <p:sp>
         <p:nvSpPr>
@@ -4231,6 +4283,10 @@
             <a:prstDash val="solid"/>
           </a:ln>
         </p:spPr>
+        <p:txBody>
+          <a:bodyPr/>
+          <a:p/>
+        </p:txBody>
       </p:sp>
       <p:sp>
         <p:nvSpPr>
@@ -4256,6 +4312,10 @@
             <a:prstDash val="solid"/>
           </a:ln>
         </p:spPr>
+        <p:txBody>
+          <a:bodyPr/>
+          <a:p/>
+        </p:txBody>
       </p:sp>
       <p:sp>
         <p:nvSpPr>
@@ -4437,6 +4497,10 @@
             <a:prstDash val="solid"/>
           </a:ln>
         </p:spPr>
+        <p:txBody>
+          <a:bodyPr/>
+          <a:p/>
+        </p:txBody>
       </p:sp>
       <p:sp>
         <p:nvSpPr>
@@ -4464,6 +4528,10 @@
             <a:prstDash val="solid"/>
           </a:ln>
         </p:spPr>
+        <p:txBody>
+          <a:bodyPr/>
+          <a:p/>
+        </p:txBody>
       </p:sp>
       <p:sp>
         <p:nvSpPr>
@@ -4489,6 +4557,10 @@
             <a:prstDash val="solid"/>
           </a:ln>
         </p:spPr>
+        <p:txBody>
+          <a:bodyPr/>
+          <a:p/>
+        </p:txBody>
       </p:sp>
       <p:sp>
         <p:nvSpPr>
@@ -5008,6 +5080,10 @@
             <a:prstDash val="solid"/>
           </a:ln>
         </p:spPr>
+        <p:txBody>
+          <a:bodyPr/>
+          <a:p/>
+        </p:txBody>
       </p:sp>
       <p:sp>
         <p:nvSpPr>
@@ -5357,7 +5433,7 @@
                   <a:schemeClr val="bg1"/>
                 </a:solidFill>
               </a:rPr>
-              <a:t>I'd like to build this with you as an APM at Ownly</a:t>
+              <a:t>Let's discuss the findings and what to test next.</a:t>
             </a:r>
             <a:endParaRPr lang="en-US" sz="3600" dirty="0"/>
           </a:p>
@@ -5389,6 +5465,10 @@
             <a:prstDash val="solid"/>
           </a:ln>
         </p:spPr>
+        <p:txBody>
+          <a:bodyPr/>
+          <a:p/>
+        </p:txBody>
       </p:sp>
       <p:sp>
         <p:nvSpPr>
@@ -5478,6 +5558,10 @@
             <a:prstDash val="solid"/>
           </a:ln>
         </p:spPr>
+        <p:txBody>
+          <a:bodyPr/>
+          <a:p/>
+        </p:txBody>
       </p:sp>
       <p:sp>
         <p:nvSpPr>
@@ -5567,6 +5651,10 @@
             <a:prstDash val="solid"/>
           </a:ln>
         </p:spPr>
+        <p:txBody>
+          <a:bodyPr/>
+          <a:p/>
+        </p:txBody>
       </p:sp>
       <p:sp>
         <p:nvSpPr>

</xml_diff>